<commit_message>
Remove poster assets and helper scripts
Clean up the poster/ directory by deleting obsolete poster exports, generated figures, logos, and auxiliary scripts. Removed older PDFs, multiple _figs/*.png images, and build/helper scripts (_build_results.py, _figs_results.py, _make_architecture.py, _swap_arch.py, _dump.py). The Project 14 presentation (V3.pptx) was also updated. This commit prunes generated/artifact files and tooling related to poster generation.
</commit_message>
<xml_diff>
--- a/poster/Predictive Modeling of Root-Zone Variables Using Greenhouse Data - Project 14 V3.pptx
+++ b/poster/Predictive Modeling of Root-Zone Variables Using Greenhouse Data - Project 14 V3.pptx
@@ -257,7 +257,7 @@
             <a:fld id="{0158C5BC-9A70-462C-B28D-9600239EAC64}" type="datetimeFigureOut">
               <a:rPr lang="en-US" smtClean="0"/>
               <a:pPr/>
-              <a:t>6/6/2026</a:t>
+              <a:t>6/7/2026</a:t>
             </a:fld>
             <a:endParaRPr lang="en-US"/>
           </a:p>
@@ -424,7 +424,7 @@
             <a:fld id="{E6CC2317-6751-4CD4-9995-8782DD78E936}" type="datetimeFigureOut">
               <a:rPr lang="en-US" smtClean="0"/>
               <a:pPr/>
-              <a:t>6/6/2026</a:t>
+              <a:t>6/7/2026</a:t>
             </a:fld>
             <a:endParaRPr lang="en-US" dirty="0"/>
           </a:p>
@@ -14671,7 +14671,7 @@
           </a:fontRef>
         </p:style>
         <p:txBody>
-          <a:bodyPr wrap="square" lIns="18000" tIns="18000" rIns="18000" bIns="18000" rtlCol="0" anchor="ctr"/>
+          <a:bodyPr wrap="square" lIns="18000" tIns="18000" rIns="18000" bIns="18000" numCol="1" rtlCol="0" anchor="ctr"/>
           <a:lstStyle/>
           <a:p>
             <a:pPr algn="ctr">
@@ -14686,7 +14686,7 @@
               </a:spcAft>
             </a:pPr>
             <a:r>
-              <a:rPr sz="3300" b="1" i="0" dirty="0">
+              <a:rPr sz="3600" b="1" i="0" dirty="0">
                 <a:solidFill>
                   <a:srgbClr val="3D4A1F"/>
                 </a:solidFill>
@@ -14694,21 +14694,17 @@
               </a:rPr>
               <a:t>0.33</a:t>
             </a:r>
-          </a:p>
-          <a:p>
-            <a:pPr algn="ctr">
-              <a:lnSpc>
-                <a:spcPct val="95000"/>
-              </a:lnSpc>
-              <a:spcBef>
-                <a:spcPts val="100"/>
-              </a:spcBef>
-              <a:spcAft>
-                <a:spcPts val="0"/>
-              </a:spcAft>
-            </a:pPr>
             <a:r>
-              <a:rPr sz="1700" b="1" i="0" dirty="0">
+              <a:rPr lang="he-IL" sz="3600" b="1" i="0" dirty="0">
+                <a:solidFill>
+                  <a:srgbClr val="3D4A1F"/>
+                </a:solidFill>
+                <a:latin typeface="Calibri"/>
+              </a:rPr>
+              <a:t> </a:t>
+            </a:r>
+            <a:r>
+              <a:rPr sz="3600" b="1" i="0" dirty="0">
                 <a:solidFill>
                   <a:srgbClr val="2E3517"/>
                 </a:solidFill>
@@ -14758,7 +14754,7 @@
           </a:fontRef>
         </p:style>
         <p:txBody>
-          <a:bodyPr wrap="square" lIns="18000" tIns="18000" rIns="18000" bIns="18000" rtlCol="0" anchor="ctr"/>
+          <a:bodyPr wrap="square" lIns="18000" tIns="18000" rIns="18000" bIns="18000" numCol="1" rtlCol="0" anchor="ctr"/>
           <a:lstStyle/>
           <a:p>
             <a:pPr algn="ctr">
@@ -14773,7 +14769,7 @@
               </a:spcAft>
             </a:pPr>
             <a:r>
-              <a:rPr sz="3300" b="1" i="0" dirty="0">
+              <a:rPr sz="3600" b="1" i="0" dirty="0">
                 <a:solidFill>
                   <a:srgbClr val="3D4A1F"/>
                 </a:solidFill>
@@ -14781,21 +14777,17 @@
               </a:rPr>
               <a:t>0.93</a:t>
             </a:r>
-          </a:p>
-          <a:p>
-            <a:pPr algn="ctr">
-              <a:lnSpc>
-                <a:spcPct val="95000"/>
-              </a:lnSpc>
-              <a:spcBef>
-                <a:spcPts val="100"/>
-              </a:spcBef>
-              <a:spcAft>
-                <a:spcPts val="0"/>
-              </a:spcAft>
-            </a:pPr>
             <a:r>
-              <a:rPr sz="1700" b="1" i="0" dirty="0">
+              <a:rPr lang="he-IL" sz="3600" b="1" i="0" dirty="0">
+                <a:solidFill>
+                  <a:srgbClr val="3D4A1F"/>
+                </a:solidFill>
+                <a:latin typeface="Calibri"/>
+              </a:rPr>
+              <a:t> </a:t>
+            </a:r>
+            <a:r>
+              <a:rPr sz="3600" b="1" i="0" dirty="0">
                 <a:solidFill>
                   <a:srgbClr val="2E3517"/>
                 </a:solidFill>
@@ -14845,7 +14837,7 @@
           </a:fontRef>
         </p:style>
         <p:txBody>
-          <a:bodyPr wrap="square" lIns="18000" tIns="18000" rIns="18000" bIns="18000" rtlCol="0" anchor="ctr"/>
+          <a:bodyPr wrap="square" lIns="18000" tIns="18000" rIns="18000" bIns="18000" numCol="1" rtlCol="0" anchor="ctr"/>
           <a:lstStyle/>
           <a:p>
             <a:pPr algn="ctr">
@@ -14860,7 +14852,7 @@
               </a:spcAft>
             </a:pPr>
             <a:r>
-              <a:rPr sz="3300" b="1" i="0" dirty="0">
+              <a:rPr sz="3600" b="1" i="0" dirty="0">
                 <a:solidFill>
                   <a:srgbClr val="B98212"/>
                 </a:solidFill>
@@ -14868,27 +14860,23 @@
               </a:rPr>
               <a:t>+62%</a:t>
             </a:r>
-          </a:p>
-          <a:p>
-            <a:pPr algn="ctr">
-              <a:lnSpc>
-                <a:spcPct val="95000"/>
-              </a:lnSpc>
-              <a:spcBef>
-                <a:spcPts val="100"/>
-              </a:spcBef>
-              <a:spcAft>
-                <a:spcPts val="0"/>
-              </a:spcAft>
-            </a:pPr>
             <a:r>
-              <a:rPr sz="1700" b="1" i="0" dirty="0">
+              <a:rPr lang="he-IL" sz="3600" b="1" i="0" dirty="0">
+                <a:solidFill>
+                  <a:srgbClr val="B98212"/>
+                </a:solidFill>
+                <a:latin typeface="Calibri"/>
+              </a:rPr>
+              <a:t> </a:t>
+            </a:r>
+            <a:r>
+              <a:rPr sz="3600" b="1" i="0" dirty="0">
                 <a:solidFill>
                   <a:srgbClr val="2E3517"/>
                 </a:solidFill>
                 <a:latin typeface="Calibri"/>
               </a:rPr>
-              <a:t>pH MAE gain</a:t>
+              <a:t>pH gain</a:t>
             </a:r>
           </a:p>
         </p:txBody>
@@ -14932,7 +14920,7 @@
           </a:fontRef>
         </p:style>
         <p:txBody>
-          <a:bodyPr wrap="square" lIns="18000" tIns="18000" rIns="18000" bIns="18000" rtlCol="0" anchor="ctr"/>
+          <a:bodyPr wrap="square" lIns="18000" tIns="18000" rIns="18000" bIns="18000" numCol="1" rtlCol="0" anchor="ctr"/>
           <a:lstStyle/>
           <a:p>
             <a:pPr algn="ctr">
@@ -14947,7 +14935,7 @@
               </a:spcAft>
             </a:pPr>
             <a:r>
-              <a:rPr sz="3300" b="1" i="0" dirty="0">
+              <a:rPr sz="3600" b="1" i="0" dirty="0">
                 <a:solidFill>
                   <a:srgbClr val="3D4A1F"/>
                 </a:solidFill>
@@ -14955,21 +14943,17 @@
               </a:rPr>
               <a:t>0.127</a:t>
             </a:r>
-          </a:p>
-          <a:p>
-            <a:pPr algn="ctr">
-              <a:lnSpc>
-                <a:spcPct val="95000"/>
-              </a:lnSpc>
-              <a:spcBef>
-                <a:spcPts val="100"/>
-              </a:spcBef>
-              <a:spcAft>
-                <a:spcPts val="0"/>
-              </a:spcAft>
-            </a:pPr>
             <a:r>
-              <a:rPr sz="1700" b="1" i="0" dirty="0">
+              <a:rPr lang="he-IL" sz="3600" b="1" i="0" dirty="0">
+                <a:solidFill>
+                  <a:srgbClr val="3D4A1F"/>
+                </a:solidFill>
+                <a:latin typeface="Calibri"/>
+              </a:rPr>
+              <a:t> </a:t>
+            </a:r>
+            <a:r>
+              <a:rPr sz="3600" b="1" i="0" dirty="0">
                 <a:solidFill>
                   <a:srgbClr val="2E3517"/>
                 </a:solidFill>
@@ -15019,7 +15003,7 @@
           </a:fontRef>
         </p:style>
         <p:txBody>
-          <a:bodyPr wrap="square" lIns="18000" tIns="18000" rIns="18000" bIns="18000" rtlCol="0" anchor="ctr"/>
+          <a:bodyPr wrap="square" lIns="18000" tIns="18000" rIns="18000" bIns="18000" numCol="1" rtlCol="0" anchor="ctr"/>
           <a:lstStyle/>
           <a:p>
             <a:pPr algn="ctr">
@@ -15034,7 +15018,7 @@
               </a:spcAft>
             </a:pPr>
             <a:r>
-              <a:rPr sz="3300" b="1" i="0" dirty="0">
+              <a:rPr sz="3600" b="1" i="0" dirty="0">
                 <a:solidFill>
                   <a:srgbClr val="3D4A1F"/>
                 </a:solidFill>
@@ -15042,21 +15026,17 @@
               </a:rPr>
               <a:t>0.98</a:t>
             </a:r>
-          </a:p>
-          <a:p>
-            <a:pPr algn="ctr">
-              <a:lnSpc>
-                <a:spcPct val="95000"/>
-              </a:lnSpc>
-              <a:spcBef>
-                <a:spcPts val="100"/>
-              </a:spcBef>
-              <a:spcAft>
-                <a:spcPts val="0"/>
-              </a:spcAft>
-            </a:pPr>
             <a:r>
-              <a:rPr sz="1700" b="1" i="0" dirty="0">
+              <a:rPr lang="he-IL" sz="3600" b="1" i="0" dirty="0">
+                <a:solidFill>
+                  <a:srgbClr val="3D4A1F"/>
+                </a:solidFill>
+                <a:latin typeface="Calibri"/>
+              </a:rPr>
+              <a:t> </a:t>
+            </a:r>
+            <a:r>
+              <a:rPr sz="3600" b="1" i="0" dirty="0">
                 <a:solidFill>
                   <a:srgbClr val="2E3517"/>
                 </a:solidFill>
@@ -15106,7 +15086,7 @@
           </a:fontRef>
         </p:style>
         <p:txBody>
-          <a:bodyPr wrap="square" lIns="18000" tIns="18000" rIns="18000" bIns="18000" rtlCol="0" anchor="ctr"/>
+          <a:bodyPr wrap="square" lIns="18000" tIns="18000" rIns="18000" bIns="18000" numCol="1" rtlCol="0" anchor="ctr"/>
           <a:lstStyle/>
           <a:p>
             <a:pPr algn="ctr">
@@ -15121,7 +15101,7 @@
               </a:spcAft>
             </a:pPr>
             <a:r>
-              <a:rPr sz="3300" b="1" i="0" dirty="0">
+              <a:rPr sz="3600" b="1" i="0" dirty="0">
                 <a:solidFill>
                   <a:srgbClr val="B98212"/>
                 </a:solidFill>
@@ -15129,27 +15109,23 @@
               </a:rPr>
               <a:t>+35%</a:t>
             </a:r>
-          </a:p>
-          <a:p>
-            <a:pPr algn="ctr">
-              <a:lnSpc>
-                <a:spcPct val="95000"/>
-              </a:lnSpc>
-              <a:spcBef>
-                <a:spcPts val="100"/>
-              </a:spcBef>
-              <a:spcAft>
-                <a:spcPts val="0"/>
-              </a:spcAft>
-            </a:pPr>
             <a:r>
-              <a:rPr sz="1700" b="1" i="0" dirty="0">
+              <a:rPr lang="he-IL" sz="3600" b="1" i="0" dirty="0">
+                <a:solidFill>
+                  <a:srgbClr val="B98212"/>
+                </a:solidFill>
+                <a:latin typeface="Calibri"/>
+              </a:rPr>
+              <a:t> </a:t>
+            </a:r>
+            <a:r>
+              <a:rPr sz="3600" b="1" i="0" dirty="0">
                 <a:solidFill>
                   <a:srgbClr val="2E3517"/>
                 </a:solidFill>
                 <a:latin typeface="Calibri"/>
               </a:rPr>
-              <a:t>EC MAE gain</a:t>
+              <a:t>EC gain</a:t>
             </a:r>
           </a:p>
         </p:txBody>
@@ -15963,8 +15939,8 @@
         </p:blipFill>
         <p:spPr>
           <a:xfrm>
-            <a:off x="2411036" y="29483789"/>
-            <a:ext cx="7363906" cy="5388170"/>
+            <a:off x="1674000" y="29375266"/>
+            <a:ext cx="7812900" cy="5716699"/>
           </a:xfrm>
           <a:prstGeom prst="rect">
             <a:avLst/>

</xml_diff>